<commit_message>
feat(rebrand): strip C.F.P. Montessori logo + text from PPTX master
- remove <p:pic> logo refs from all slideLayouts + slideMaster
- drop cfp_logo.jpeg media + orphan rels (0 dangling refs verified)
- cover footer + docProps + theme name -> EduVault
- add scripts/rebrand_master_to_eduvault.py (idempotent, .pre_eduvault.bak backup)
- validated: python-pptx round-trip OK, 6-slide minibuild renders, 0 CFP strings

Co-Authored-By: Claude Fable 5 <noreply@anthropic.com>
</commit_message>
<xml_diff>
--- a/assets/templates/nexus_master_v4_patched.pptx
+++ b/assets/templates/nexus_master_v4_patched.pptx
@@ -443,7 +443,7 @@
                 <a:latin typeface="Inter"/>
                 <a:cs typeface="Inter"/>
               </a:rPr>
-              <a:t>C.F.P. Montessori — Formazione Globale</a:t>
+              <a:t>EduVault</a:t>
             </a:r>
           </a:p>
         </p:txBody>
@@ -566,30 +566,6 @@
           </a:p>
         </p:txBody>
       </p:sp>
-      <p:pic>
-        <p:nvPicPr>
-          <p:cNvPr id="1007" name="nx_logo_large"/>
-          <p:cNvPicPr>
-            <a:picLocks noChangeAspect="1"/>
-          </p:cNvPicPr>
-          <p:nvPr/>
-        </p:nvPicPr>
-        <p:blipFill>
-          <a:blip r:embed="rId100"/>
-          <a:stretch>
-            <a:fillRect/>
-          </a:stretch>
-        </p:blipFill>
-        <p:spPr>
-          <a:xfrm>
-            <a:off x="5376000" y="5040000"/>
-            <a:ext cx="1440000" cy="720000"/>
-          </a:xfrm>
-          <a:prstGeom prst="rect">
-            <a:avLst/>
-          </a:prstGeom>
-        </p:spPr>
-      </p:pic>
     </p:spTree>
   </p:cSld>
   <p:clrMapOvr>
@@ -3836,30 +3812,6 @@
           <a:chExt cx="0" cy="0"/>
         </a:xfrm>
       </p:grpSpPr>
-      <p:pic>
-        <p:nvPicPr>
-          <p:cNvPr id="50" name="nx_logo"/>
-          <p:cNvPicPr>
-            <a:picLocks noChangeAspect="1"/>
-          </p:cNvPicPr>
-          <p:nvPr/>
-        </p:nvPicPr>
-        <p:blipFill>
-          <a:blip r:embed="rId100"/>
-          <a:stretch>
-            <a:fillRect/>
-          </a:stretch>
-        </p:blipFill>
-        <p:spPr>
-          <a:xfrm>
-            <a:off x="11184000" y="6318000"/>
-            <a:ext cx="900000" cy="450000"/>
-          </a:xfrm>
-          <a:prstGeom prst="rect">
-            <a:avLst/>
-          </a:prstGeom>
-        </p:spPr>
-      </p:pic>
     </p:spTree>
   </p:cSld>
   <p:clrMap bg1="lt1" tx1="dk1" bg2="lt2" tx2="dk2" accent1="accent1" accent2="accent2" accent3="accent3" accent4="accent4" accent5="accent5" accent6="accent6" hlink="hlink" folHlink="folHlink"/>
@@ -3908,9 +3860,9 @@
 </file>
 
 <file path=ppt/theme/theme1.xml><?xml version="1.0" encoding="utf-8"?>
-<a:theme xmlns:a="http://schemas.openxmlformats.org/drawingml/2006/main" name="CFP">
+<a:theme xmlns:a="http://schemas.openxmlformats.org/drawingml/2006/main" name="EduVault">
   <a:themeElements>
-    <a:clrScheme name="CFP">
+    <a:clrScheme name="EduVault">
       <a:dk1>
         <a:srgbClr val="1F1F1F"/>
       </a:dk1>
@@ -3948,7 +3900,7 @@
         <a:srgbClr val="A8255A"/>
       </a:folHlink>
     </a:clrScheme>
-    <a:fontScheme name="CFP">
+    <a:fontScheme name="EduVault">
       <a:majorFont>
         <a:latin typeface="Inter"/>
         <a:ea typeface=""/>

</xml_diff>